<commit_message>
formula explanation draft 1
</commit_message>
<xml_diff>
--- a/presentations/paper_presentation.pptx
+++ b/presentations/paper_presentation.pptx
@@ -20,9 +20,10 @@
     <p:sldId id="268" r:id="rId14"/>
     <p:sldId id="269" r:id="rId15"/>
     <p:sldId id="270" r:id="rId16"/>
+    <p:sldId id="271" r:id="rId17"/>
   </p:sldIdLst>
   <p:notesMasterIdLst>
-    <p:notesMasterId r:id="rId17"/>
+    <p:notesMasterId r:id="rId18"/>
   </p:notesMasterIdLst>
   <p:sldSz cx="12192000" cy="6858000"/>
   <p:notesSz cx="6858000" cy="12192000"/>
@@ -606,7 +607,8 @@
             <a:r>
               <a:rPr lang="en-US" dirty="0"/>
               <a:t>**Speaking script**
-This heavy-load grid is designed to expose bottlenecks and tradeoffs. It spans very low to very high traffic, with conservative to aggressive demodulator budgets.</a:t>
+These propositions justify that the model is physically coherent and mathematically stable. They are the bridge between implementation convenience and scientific defensibility.
+Validation note: this model is first-order and not hardware-calibrated.</a:t>
             </a:r>
             <a:endParaRPr lang="en-US" dirty="0"/>
           </a:p>
@@ -649,6 +651,95 @@
 </file>
 
 <file path=ppt/notesSlides/notesSlide11.xml><?xml version="1.0" encoding="utf-8"?>
+<p:notes xmlns:a="http://schemas.openxmlformats.org/drawingml/2006/main" xmlns:r="http://schemas.openxmlformats.org/officeDocument/2006/relationships" xmlns:p="http://schemas.openxmlformats.org/presentationml/2006/main">
+  <p:cSld>
+    <p:spTree>
+      <p:nvGrpSpPr>
+        <p:cNvPr id="1" name=""/>
+        <p:cNvGrpSpPr/>
+        <p:nvPr/>
+      </p:nvGrpSpPr>
+      <p:grpSpPr>
+        <a:xfrm>
+          <a:off x="0" y="0"/>
+          <a:ext cx="0" cy="0"/>
+          <a:chOff x="0" y="0"/>
+          <a:chExt cx="0" cy="0"/>
+        </a:xfrm>
+      </p:grpSpPr>
+      <p:sp>
+        <p:nvSpPr>
+          <p:cNvPr id="2" name="Slide Image Placeholder 1"/>
+          <p:cNvSpPr>
+            <a:spLocks noGrp="1" noRot="1" noChangeAspect="1"/>
+          </p:cNvSpPr>
+          <p:nvPr>
+            <p:ph type="sldImg"/>
+          </p:nvPr>
+        </p:nvSpPr>
+        <p:spPr/>
+      </p:sp>
+      <p:sp>
+        <p:nvSpPr>
+          <p:cNvPr id="3" name="Notes Placeholder 2"/>
+          <p:cNvSpPr>
+            <a:spLocks noGrp="1"/>
+          </p:cNvSpPr>
+          <p:nvPr>
+            <p:ph type="body" idx="1"/>
+          </p:nvPr>
+        </p:nvSpPr>
+        <p:spPr/>
+        <p:txBody>
+          <a:bodyPr/>
+          <a:lstStyle/>
+          <a:p>
+            <a:r>
+              <a:rPr lang="en-US" dirty="0"/>
+              <a:t>**Speaking script**
+This heavy-load grid is designed to expose bottlenecks and tradeoffs. It spans very low to very high traffic, with conservative to aggressive demodulator budgets.</a:t>
+            </a:r>
+            <a:endParaRPr lang="en-US" dirty="0"/>
+          </a:p>
+        </p:txBody>
+      </p:sp>
+      <p:sp>
+        <p:nvSpPr>
+          <p:cNvPr id="4" name="Slide Number Placeholder 3"/>
+          <p:cNvSpPr>
+            <a:spLocks noGrp="1"/>
+          </p:cNvSpPr>
+          <p:nvPr>
+            <p:ph type="sldNum" sz="quarter" idx="10"/>
+          </p:nvPr>
+        </p:nvSpPr>
+        <p:spPr/>
+        <p:txBody>
+          <a:bodyPr/>
+          <a:lstStyle/>
+          <a:p>
+            <a:fld id="{F7021451-1387-4CA6-816F-3879F97B5CBC}" type="slidenum">
+              <a:rPr lang="en-US"/>
+              <a:t>11</a:t>
+            </a:fld>
+            <a:endParaRPr lang="en-US"/>
+          </a:p>
+        </p:txBody>
+      </p:sp>
+    </p:spTree>
+    <p:extLst>
+      <p:ext uri="{BB962C8B-B14F-4D97-AF65-F5344CB8AC3E}">
+        <p14:creationId xmlns:p14="http://schemas.microsoft.com/office/powerpoint/2010/main" val="1024086991"/>
+      </p:ext>
+    </p:extLst>
+  </p:cSld>
+  <p:clrMapOvr>
+    <a:masterClrMapping/>
+  </p:clrMapOvr>
+</p:notes>
+</file>
+
+<file path=ppt/notesSlides/notesSlide12.xml><?xml version="1.0" encoding="utf-8"?>
 <p:notes xmlns:a="http://schemas.openxmlformats.org/drawingml/2006/main" xmlns:r="http://schemas.openxmlformats.org/officeDocument/2006/relationships" xmlns:p="http://schemas.openxmlformats.org/presentationml/2006/main">
   <p:cSld>
     <p:spTree>
@@ -718,7 +809,7 @@
           <a:p>
             <a:fld id="{F7021451-1387-4CA6-816F-3879F97B5CBC}" type="slidenum">
               <a:rPr lang="en-US"/>
-              <a:t>11</a:t>
+              <a:t>12</a:t>
             </a:fld>
             <a:endParaRPr lang="en-US"/>
           </a:p>
@@ -737,7 +828,7 @@
 </p:notes>
 </file>
 
-<file path=ppt/notesSlides/notesSlide12.xml><?xml version="1.0" encoding="utf-8"?>
+<file path=ppt/notesSlides/notesSlide13.xml><?xml version="1.0" encoding="utf-8"?>
 <p:notes xmlns:a="http://schemas.openxmlformats.org/drawingml/2006/main" xmlns:r="http://schemas.openxmlformats.org/officeDocument/2006/relationships" xmlns:p="http://schemas.openxmlformats.org/presentationml/2006/main">
   <p:cSld>
     <p:spTree>
@@ -807,7 +898,7 @@
           <a:p>
             <a:fld id="{F7021451-1387-4CA6-816F-3879F97B5CBC}" type="slidenum">
               <a:rPr lang="en-US"/>
-              <a:t>12</a:t>
+              <a:t>13</a:t>
             </a:fld>
             <a:endParaRPr lang="en-US"/>
           </a:p>
@@ -826,7 +917,7 @@
 </p:notes>
 </file>
 
-<file path=ppt/notesSlides/notesSlide13.xml><?xml version="1.0" encoding="utf-8"?>
+<file path=ppt/notesSlides/notesSlide14.xml><?xml version="1.0" encoding="utf-8"?>
 <p:notes xmlns:a="http://schemas.openxmlformats.org/drawingml/2006/main" xmlns:r="http://schemas.openxmlformats.org/officeDocument/2006/relationships" xmlns:p="http://schemas.openxmlformats.org/presentationml/2006/main">
   <p:cSld>
     <p:spTree>
@@ -896,7 +987,7 @@
           <a:p>
             <a:fld id="{F7021451-1387-4CA6-816F-3879F97B5CBC}" type="slidenum">
               <a:rPr lang="en-US"/>
-              <a:t>13</a:t>
+              <a:t>14</a:t>
             </a:fld>
             <a:endParaRPr lang="en-US"/>
           </a:p>
@@ -915,7 +1006,7 @@
 </p:notes>
 </file>
 
-<file path=ppt/notesSlides/notesSlide14.xml><?xml version="1.0" encoding="utf-8"?>
+<file path=ppt/notesSlides/notesSlide15.xml><?xml version="1.0" encoding="utf-8"?>
 <p:notes xmlns:a="http://schemas.openxmlformats.org/drawingml/2006/main" xmlns:r="http://schemas.openxmlformats.org/officeDocument/2006/relationships" xmlns:p="http://schemas.openxmlformats.org/presentationml/2006/main">
   <p:cSld>
     <p:spTree>
@@ -985,7 +1076,7 @@
           <a:p>
             <a:fld id="{F7021451-1387-4CA6-816F-3879F97B5CBC}" type="slidenum">
               <a:rPr lang="en-US"/>
-              <a:t>14</a:t>
+              <a:t>15</a:t>
             </a:fld>
             <a:endParaRPr lang="en-US"/>
           </a:p>
@@ -1004,7 +1095,7 @@
 </p:notes>
 </file>
 
-<file path=ppt/notesSlides/notesSlide15.xml><?xml version="1.0" encoding="utf-8"?>
+<file path=ppt/notesSlides/notesSlide16.xml><?xml version="1.0" encoding="utf-8"?>
 <p:notes xmlns:a="http://schemas.openxmlformats.org/drawingml/2006/main" xmlns:r="http://schemas.openxmlformats.org/officeDocument/2006/relationships" xmlns:p="http://schemas.openxmlformats.org/presentationml/2006/main">
   <p:cSld>
     <p:spTree>
@@ -1074,7 +1165,7 @@
           <a:p>
             <a:fld id="{F7021451-1387-4CA6-816F-3879F97B5CBC}" type="slidenum">
               <a:rPr lang="en-US"/>
-              <a:t>15</a:t>
+              <a:t>16</a:t>
             </a:fld>
             <a:endParaRPr lang="en-US"/>
           </a:p>
@@ -1496,7 +1587,14 @@
             <a:r>
               <a:rPr lang="en-US" dirty="0"/>
               <a:t>**Speaking script**
-We use a bounded utilization model and an affine, mode-dependent power law. This captures low-to-high activity transitions while keeping the model simple and controllable.</a:t>
+We use a bounded utilization model and an affine, mode-dependent power law. This captures low-to-high activity transitions while keeping the model simple and controllable.
+Details:
+- rho is utilization ratio; N_t/(8D) is demand/capacity.
+- min(1, .) caps utilization at 100%, with rho &lt; 1 underutilized and rho = 1 saturated.
+- Queue-free approximation: no buffering modeled.
+- Equivalent compact form: P_total = P_base + P_RF + D * P_demod(rho).
+- Power scales linearly with D; per-demod power is bounded from idle to peak.
+- Assumes independent demodulator scaling (no shared bottleneck).</a:t>
             </a:r>
             <a:endParaRPr lang="en-US" dirty="0"/>
           </a:p>
@@ -1585,7 +1683,17 @@
             <a:r>
               <a:rPr lang="en-US" dirty="0"/>
               <a:t>**Speaking script**
-Visibility gates generation, and the battery evolves from net power after efficiency losses. The clip operation enforces physical SoC bounds between 0 and 100 percent.</a:t>
+Visibility gates generation, and the battery evolves from net power after efficiency losses. The clip operation enforces physical SoC bounds between 0 and 100 percent.
+Apanel is panel area (m2), Gsun is solar irradiance
+(W/m2), and ηpanel is dimensionless efficiency
+Details:
+- G_sun is approximately 1361 W/m^2 in space.
+- During eclipse, P_gen = 0.
+- No incidence-angle loss is modeled.
+- P_net &gt; 0 means charging, P_net &lt; 0 means discharging.
+- DeltaE uses eta_ch * max(P_net,0) * Delta t - (1/eta_dis) * max(-P_net,0) * Delta t.
+- Delta t must be in hours for Wh consistency.
+- SoC update is linearized and ignores nonlinear battery-voltage behavior.</a:t>
             </a:r>
             <a:endParaRPr lang="en-US" dirty="0"/>
           </a:p>
@@ -1673,8 +1781,7 @@
           <a:p>
             <a:r>
               <a:rPr lang="en-US" dirty="0"/>
-              <a:t>**Speaking script**
-We intentionally use a first-order CC-CV-inspired taper to represent practical charge saturation behavior, without adding heavy electrochemical complexity.</a:t>
+              <a:t/>
             </a:r>
             <a:endParaRPr lang="en-US" dirty="0"/>
           </a:p>
@@ -1763,7 +1870,12 @@
             <a:r>
               <a:rPr lang="en-US" dirty="0"/>
               <a:t>**Speaking script**
-These propositions justify that the model is physically coherent and mathematically stable. They are the bridge between implementation convenience and scientific defensibility.</a:t>
+We intentionally use a first-order CC-CV-inspired taper to represent practical charge saturation behavior, without adding heavy electrochemical complexity.
+Assumptions:
+- ideal battery model
+- no thermal effects
+- linear/affine power scaling
+- no degradation/aging dynamics</a:t>
             </a:r>
             <a:endParaRPr lang="en-US" dirty="0"/>
           </a:p>
@@ -2349,6 +2461,45 @@
 <file path=ppt/slides/slide15.xml><?xml version="1.0" encoding="utf-8"?>
 <p:sld xmlns:a="http://schemas.openxmlformats.org/drawingml/2006/main" xmlns:r="http://schemas.openxmlformats.org/officeDocument/2006/relationships" xmlns:p="http://schemas.openxmlformats.org/presentationml/2006/main">
   <p:cSld name="Slide 15">
+    <p:bg>
+      <p:bgPr>
+        <a:blipFill dpi="0" rotWithShape="1">
+          <a:blip r:embed="rId1">
+            <a:lum/>
+          </a:blip>
+          <a:srcRect/>
+          <a:stretch>
+            <a:fillRect/>
+          </a:stretch>
+        </a:blipFill>
+        <a:effectLst/>
+      </p:bgPr>
+    </p:bg>
+    <p:spTree>
+      <p:nvGrpSpPr>
+        <p:cNvPr id="1" name=""/>
+        <p:cNvGrpSpPr/>
+        <p:nvPr/>
+      </p:nvGrpSpPr>
+      <p:grpSpPr>
+        <a:xfrm>
+          <a:off x="0" y="0"/>
+          <a:ext cx="0" cy="0"/>
+          <a:chOff x="0" y="0"/>
+          <a:chExt cx="0" cy="0"/>
+        </a:xfrm>
+      </p:grpSpPr>
+    </p:spTree>
+  </p:cSld>
+  <p:clrMapOvr>
+    <a:masterClrMapping/>
+  </p:clrMapOvr>
+</p:sld>
+</file>
+
+<file path=ppt/slides/slide16.xml><?xml version="1.0" encoding="utf-8"?>
+<p:sld xmlns:a="http://schemas.openxmlformats.org/drawingml/2006/main" xmlns:r="http://schemas.openxmlformats.org/officeDocument/2006/relationships" xmlns:p="http://schemas.openxmlformats.org/presentationml/2006/main">
+  <p:cSld name="Slide 16">
     <p:bg>
       <p:bgPr>
         <a:blipFill dpi="0" rotWithShape="1">

</xml_diff>